<commit_message>
Apply approved Pagemi paper character across app and decks
</commit_message>
<xml_diff>
--- a/docs/submission/Pagemi_Official_Template_2026-10-18.pptx
+++ b/docs/submission/Pagemi_Official_Template_2026-10-18.pptx
@@ -7460,6 +7460,30 @@
           </a:p>
         </p:txBody>
       </p:sp>
+      <p:pic xmlns:a="http://schemas.openxmlformats.org/drawingml/2006/main" xmlns:r="http://schemas.openxmlformats.org/officeDocument/2006/relationships">
+        <p:nvPicPr>
+          <p:cNvPr id="59" name="Pagemi Logo 03 cover" descr="pagemi-mark.png"/>
+          <p:cNvPicPr>
+            <a:picLocks noChangeAspect="1"/>
+          </p:cNvPicPr>
+          <p:nvPr/>
+        </p:nvPicPr>
+        <p:blipFill>
+          <a:blip r:embed="rId5"/>
+          <a:stretch>
+            <a:fillRect/>
+          </a:stretch>
+        </p:blipFill>
+        <p:spPr>
+          <a:xfrm>
+            <a:off x="7223760" y="2907792"/>
+            <a:ext cx="1417320" cy="1417320"/>
+          </a:xfrm>
+          <a:prstGeom prst="rect">
+            <a:avLst/>
+          </a:prstGeom>
+        </p:spPr>
+      </p:pic>
     </p:spTree>
     <p:extLst>
       <p:ext uri="{BB962C8B-B14F-4D97-AF65-F5344CB8AC3E}">
@@ -8059,6 +8083,30 @@
           </a:p>
         </p:txBody>
       </p:sp>
+      <p:pic xmlns:a="http://schemas.openxmlformats.org/drawingml/2006/main" xmlns:r="http://schemas.openxmlformats.org/officeDocument/2006/relationships">
+        <p:nvPicPr>
+          <p:cNvPr id="129" name="Pagemi Logo 03 footer" descr="pagemi-mark.png"/>
+          <p:cNvPicPr>
+            <a:picLocks noChangeAspect="1"/>
+          </p:cNvPicPr>
+          <p:nvPr/>
+        </p:nvPicPr>
+        <p:blipFill>
+          <a:blip r:embed="rId5"/>
+          <a:stretch>
+            <a:fillRect/>
+          </a:stretch>
+        </p:blipFill>
+        <p:spPr>
+          <a:xfrm>
+            <a:off x="8284464" y="4590288"/>
+            <a:ext cx="411480" cy="411480"/>
+          </a:xfrm>
+          <a:prstGeom prst="rect">
+            <a:avLst/>
+          </a:prstGeom>
+        </p:spPr>
+      </p:pic>
     </p:spTree>
     <p:extLst>
       <p:ext uri="{BB962C8B-B14F-4D97-AF65-F5344CB8AC3E}">
@@ -8614,6 +8662,30 @@
           </a:p>
         </p:txBody>
       </p:sp>
+      <p:pic xmlns:a="http://schemas.openxmlformats.org/drawingml/2006/main" xmlns:r="http://schemas.openxmlformats.org/officeDocument/2006/relationships">
+        <p:nvPicPr>
+          <p:cNvPr id="138" name="Pagemi Logo 03 footer" descr="pagemi-mark.png"/>
+          <p:cNvPicPr>
+            <a:picLocks noChangeAspect="1"/>
+          </p:cNvPicPr>
+          <p:nvPr/>
+        </p:nvPicPr>
+        <p:blipFill>
+          <a:blip r:embed="rId6"/>
+          <a:stretch>
+            <a:fillRect/>
+          </a:stretch>
+        </p:blipFill>
+        <p:spPr>
+          <a:xfrm>
+            <a:off x="8284464" y="4590288"/>
+            <a:ext cx="411480" cy="411480"/>
+          </a:xfrm>
+          <a:prstGeom prst="rect">
+            <a:avLst/>
+          </a:prstGeom>
+        </p:spPr>
+      </p:pic>
     </p:spTree>
     <p:extLst>
       <p:ext uri="{BB962C8B-B14F-4D97-AF65-F5344CB8AC3E}">
@@ -9213,6 +9285,30 @@
           </a:p>
         </p:txBody>
       </p:sp>
+      <p:pic xmlns:a="http://schemas.openxmlformats.org/drawingml/2006/main" xmlns:r="http://schemas.openxmlformats.org/officeDocument/2006/relationships">
+        <p:nvPicPr>
+          <p:cNvPr id="145" name="Pagemi Logo 03 footer" descr="pagemi-mark.png"/>
+          <p:cNvPicPr>
+            <a:picLocks noChangeAspect="1"/>
+          </p:cNvPicPr>
+          <p:nvPr/>
+        </p:nvPicPr>
+        <p:blipFill>
+          <a:blip r:embed="rId5"/>
+          <a:stretch>
+            <a:fillRect/>
+          </a:stretch>
+        </p:blipFill>
+        <p:spPr>
+          <a:xfrm>
+            <a:off x="8284464" y="4590288"/>
+            <a:ext cx="411480" cy="411480"/>
+          </a:xfrm>
+          <a:prstGeom prst="rect">
+            <a:avLst/>
+          </a:prstGeom>
+        </p:spPr>
+      </p:pic>
     </p:spTree>
     <p:extLst>
       <p:ext uri="{BB962C8B-B14F-4D97-AF65-F5344CB8AC3E}">
@@ -9788,6 +9884,30 @@
           </a:p>
         </p:txBody>
       </p:sp>
+      <p:pic xmlns:a="http://schemas.openxmlformats.org/drawingml/2006/main" xmlns:r="http://schemas.openxmlformats.org/officeDocument/2006/relationships">
+        <p:nvPicPr>
+          <p:cNvPr id="153" name="Pagemi Logo 03 footer" descr="pagemi-mark.png"/>
+          <p:cNvPicPr>
+            <a:picLocks noChangeAspect="1"/>
+          </p:cNvPicPr>
+          <p:nvPr/>
+        </p:nvPicPr>
+        <p:blipFill>
+          <a:blip r:embed="rId5"/>
+          <a:stretch>
+            <a:fillRect/>
+          </a:stretch>
+        </p:blipFill>
+        <p:spPr>
+          <a:xfrm>
+            <a:off x="8284464" y="4590288"/>
+            <a:ext cx="411480" cy="411480"/>
+          </a:xfrm>
+          <a:prstGeom prst="rect">
+            <a:avLst/>
+          </a:prstGeom>
+        </p:spPr>
+      </p:pic>
     </p:spTree>
     <p:extLst>
       <p:ext uri="{BB962C8B-B14F-4D97-AF65-F5344CB8AC3E}">
@@ -10387,6 +10507,30 @@
           </a:p>
         </p:txBody>
       </p:sp>
+      <p:pic xmlns:a="http://schemas.openxmlformats.org/drawingml/2006/main" xmlns:r="http://schemas.openxmlformats.org/officeDocument/2006/relationships">
+        <p:nvPicPr>
+          <p:cNvPr id="161" name="Pagemi Logo 03 footer" descr="pagemi-mark.png"/>
+          <p:cNvPicPr>
+            <a:picLocks noChangeAspect="1"/>
+          </p:cNvPicPr>
+          <p:nvPr/>
+        </p:nvPicPr>
+        <p:blipFill>
+          <a:blip r:embed="rId5"/>
+          <a:stretch>
+            <a:fillRect/>
+          </a:stretch>
+        </p:blipFill>
+        <p:spPr>
+          <a:xfrm>
+            <a:off x="8284464" y="4590288"/>
+            <a:ext cx="411480" cy="411480"/>
+          </a:xfrm>
+          <a:prstGeom prst="rect">
+            <a:avLst/>
+          </a:prstGeom>
+        </p:spPr>
+      </p:pic>
     </p:spTree>
     <p:extLst>
       <p:ext uri="{BB962C8B-B14F-4D97-AF65-F5344CB8AC3E}">
@@ -10973,6 +11117,30 @@
           </a:p>
         </p:txBody>
       </p:sp>
+      <p:pic xmlns:a="http://schemas.openxmlformats.org/drawingml/2006/main" xmlns:r="http://schemas.openxmlformats.org/officeDocument/2006/relationships">
+        <p:nvPicPr>
+          <p:cNvPr id="169" name="Pagemi Logo 03 footer" descr="pagemi-mark.png"/>
+          <p:cNvPicPr>
+            <a:picLocks noChangeAspect="1"/>
+          </p:cNvPicPr>
+          <p:nvPr/>
+        </p:nvPicPr>
+        <p:blipFill>
+          <a:blip r:embed="rId5"/>
+          <a:stretch>
+            <a:fillRect/>
+          </a:stretch>
+        </p:blipFill>
+        <p:spPr>
+          <a:xfrm>
+            <a:off x="8284464" y="4590288"/>
+            <a:ext cx="411480" cy="411480"/>
+          </a:xfrm>
+          <a:prstGeom prst="rect">
+            <a:avLst/>
+          </a:prstGeom>
+        </p:spPr>
+      </p:pic>
     </p:spTree>
     <p:extLst>
       <p:ext uri="{BB962C8B-B14F-4D97-AF65-F5344CB8AC3E}">
@@ -11062,6 +11230,30 @@
           <a:ln xmlns:a="http://schemas.openxmlformats.org/drawingml/2006/main">
             <a:noFill/>
           </a:ln>
+        </p:spPr>
+      </p:pic>
+      <p:pic xmlns:a="http://schemas.openxmlformats.org/drawingml/2006/main" xmlns:r="http://schemas.openxmlformats.org/officeDocument/2006/relationships">
+        <p:nvPicPr>
+          <p:cNvPr id="173" name="Pagemi Logo 03 closing" descr="pagemi-mark.png"/>
+          <p:cNvPicPr>
+            <a:picLocks noChangeAspect="1"/>
+          </p:cNvPicPr>
+          <p:nvPr/>
+        </p:nvPicPr>
+        <p:blipFill>
+          <a:blip r:embed="rId5"/>
+          <a:stretch>
+            <a:fillRect/>
+          </a:stretch>
+        </p:blipFill>
+        <p:spPr>
+          <a:xfrm>
+            <a:off x="7863840" y="292608"/>
+            <a:ext cx="777240" cy="777240"/>
+          </a:xfrm>
+          <a:prstGeom prst="rect">
+            <a:avLst/>
+          </a:prstGeom>
         </p:spPr>
       </p:pic>
     </p:spTree>
@@ -11639,6 +11831,30 @@
           </a:p>
         </p:txBody>
       </p:sp>
+      <p:pic xmlns:a="http://schemas.openxmlformats.org/drawingml/2006/main" xmlns:r="http://schemas.openxmlformats.org/officeDocument/2006/relationships">
+        <p:nvPicPr>
+          <p:cNvPr id="66" name="Pagemi Logo 03 footer" descr="pagemi-mark.png"/>
+          <p:cNvPicPr>
+            <a:picLocks noChangeAspect="1"/>
+          </p:cNvPicPr>
+          <p:nvPr/>
+        </p:nvPicPr>
+        <p:blipFill>
+          <a:blip r:embed="rId5"/>
+          <a:stretch>
+            <a:fillRect/>
+          </a:stretch>
+        </p:blipFill>
+        <p:spPr>
+          <a:xfrm>
+            <a:off x="8284464" y="4590288"/>
+            <a:ext cx="411480" cy="411480"/>
+          </a:xfrm>
+          <a:prstGeom prst="rect">
+            <a:avLst/>
+          </a:prstGeom>
+        </p:spPr>
+      </p:pic>
     </p:spTree>
     <p:extLst>
       <p:ext uri="{BB962C8B-B14F-4D97-AF65-F5344CB8AC3E}">
@@ -12132,6 +12348,30 @@
           </a:p>
         </p:txBody>
       </p:sp>
+      <p:pic xmlns:a="http://schemas.openxmlformats.org/drawingml/2006/main" xmlns:r="http://schemas.openxmlformats.org/officeDocument/2006/relationships">
+        <p:nvPicPr>
+          <p:cNvPr id="73" name="Pagemi Logo 03 footer" descr="pagemi-mark.png"/>
+          <p:cNvPicPr>
+            <a:picLocks noChangeAspect="1"/>
+          </p:cNvPicPr>
+          <p:nvPr/>
+        </p:nvPicPr>
+        <p:blipFill>
+          <a:blip r:embed="rId4"/>
+          <a:stretch>
+            <a:fillRect/>
+          </a:stretch>
+        </p:blipFill>
+        <p:spPr>
+          <a:xfrm>
+            <a:off x="8284464" y="4590288"/>
+            <a:ext cx="411480" cy="411480"/>
+          </a:xfrm>
+          <a:prstGeom prst="rect">
+            <a:avLst/>
+          </a:prstGeom>
+        </p:spPr>
+      </p:pic>
     </p:spTree>
     <p:extLst>
       <p:ext uri="{BB962C8B-B14F-4D97-AF65-F5344CB8AC3E}">
@@ -12659,6 +12899,30 @@
           </a:p>
         </p:txBody>
       </p:sp>
+      <p:pic xmlns:a="http://schemas.openxmlformats.org/drawingml/2006/main" xmlns:r="http://schemas.openxmlformats.org/officeDocument/2006/relationships">
+        <p:nvPicPr>
+          <p:cNvPr id="81" name="Pagemi Logo 03 footer" descr="pagemi-mark.png"/>
+          <p:cNvPicPr>
+            <a:picLocks noChangeAspect="1"/>
+          </p:cNvPicPr>
+          <p:nvPr/>
+        </p:nvPicPr>
+        <p:blipFill>
+          <a:blip r:embed="rId5"/>
+          <a:stretch>
+            <a:fillRect/>
+          </a:stretch>
+        </p:blipFill>
+        <p:spPr>
+          <a:xfrm>
+            <a:off x="8284464" y="4590288"/>
+            <a:ext cx="411480" cy="411480"/>
+          </a:xfrm>
+          <a:prstGeom prst="rect">
+            <a:avLst/>
+          </a:prstGeom>
+        </p:spPr>
+      </p:pic>
     </p:spTree>
     <p:extLst>
       <p:ext uri="{BB962C8B-B14F-4D97-AF65-F5344CB8AC3E}">
@@ -13258,6 +13522,30 @@
           </a:p>
         </p:txBody>
       </p:sp>
+      <p:pic xmlns:a="http://schemas.openxmlformats.org/drawingml/2006/main" xmlns:r="http://schemas.openxmlformats.org/officeDocument/2006/relationships">
+        <p:nvPicPr>
+          <p:cNvPr id="89" name="Pagemi Logo 03 footer" descr="pagemi-mark.png"/>
+          <p:cNvPicPr>
+            <a:picLocks noChangeAspect="1"/>
+          </p:cNvPicPr>
+          <p:nvPr/>
+        </p:nvPicPr>
+        <p:blipFill>
+          <a:blip r:embed="rId5"/>
+          <a:stretch>
+            <a:fillRect/>
+          </a:stretch>
+        </p:blipFill>
+        <p:spPr>
+          <a:xfrm>
+            <a:off x="8284464" y="4590288"/>
+            <a:ext cx="411480" cy="411480"/>
+          </a:xfrm>
+          <a:prstGeom prst="rect">
+            <a:avLst/>
+          </a:prstGeom>
+        </p:spPr>
+      </p:pic>
     </p:spTree>
     <p:extLst>
       <p:ext uri="{BB962C8B-B14F-4D97-AF65-F5344CB8AC3E}">
@@ -15925,6 +16213,30 @@
           </a:p>
         </p:txBody>
       </p:sp>
+      <p:pic xmlns:a="http://schemas.openxmlformats.org/drawingml/2006/main" xmlns:r="http://schemas.openxmlformats.org/officeDocument/2006/relationships">
+        <p:nvPicPr>
+          <p:cNvPr id="111" name="Pagemi Logo 03 footer" descr="pagemi-mark.png"/>
+          <p:cNvPicPr>
+            <a:picLocks noChangeAspect="1"/>
+          </p:cNvPicPr>
+          <p:nvPr/>
+        </p:nvPicPr>
+        <p:blipFill>
+          <a:blip r:embed="rId5"/>
+          <a:stretch>
+            <a:fillRect/>
+          </a:stretch>
+        </p:blipFill>
+        <p:spPr>
+          <a:xfrm>
+            <a:off x="8284464" y="4590288"/>
+            <a:ext cx="411480" cy="411480"/>
+          </a:xfrm>
+          <a:prstGeom prst="rect">
+            <a:avLst/>
+          </a:prstGeom>
+        </p:spPr>
+      </p:pic>
     </p:spTree>
     <p:extLst>
       <p:ext uri="{BB962C8B-B14F-4D97-AF65-F5344CB8AC3E}">
@@ -16237,30 +16549,26 @@
           </a:p>
         </p:txBody>
       </p:sp>
-      <p:pic>
+      <p:pic xmlns:a="http://schemas.openxmlformats.org/drawingml/2006/main" xmlns:r="http://schemas.openxmlformats.org/officeDocument/2006/relationships">
         <p:nvPicPr>
-          <p:cNvPr id="104" name="">
-            <a:extLst xmlns:a="http://schemas.openxmlformats.org/drawingml/2006/main">
-              <a:ext uri="{FF2B5EF4-FFF2-40B4-BE49-F238E27FC236}">
-                <a16:creationId xmlns:a16="http://schemas.microsoft.com/office/drawing/2014/main" id="{82704FA6-CB62-4C00-B75E-E72D818F815B}"/>
-              </a:ext>
-            </a:extLst>
-          </p:cNvPr>
+          <p:cNvPr id="107" name="Public Pagemi evidence workbench — 18 October 2026" descr="07-live-workbench.jpg"/>
           <p:cNvPicPr>
-            <a:picLocks xmlns:a="http://schemas.openxmlformats.org/drawingml/2006/main" noChangeAspect="1"/>
+            <a:picLocks noChangeAspect="1"/>
           </p:cNvPicPr>
           <p:nvPr/>
         </p:nvPicPr>
         <p:blipFill>
-          <a:blip xmlns:r="http://schemas.openxmlformats.org/officeDocument/2006/relationships" xmlns:a="http://schemas.openxmlformats.org/drawingml/2006/main" r:embed="R73540a0c98b54234"/>
-          <a:stretch xmlns:a="http://schemas.openxmlformats.org/drawingml/2006/main"/>
+          <a:blip r:embed="rId7"/>
+          <a:stretch>
+            <a:fillRect/>
+          </a:stretch>
         </p:blipFill>
         <p:spPr>
-          <a:xfrm xmlns:a="http://schemas.openxmlformats.org/drawingml/2006/main">
+          <a:xfrm>
             <a:off x="266700" y="1384102"/>
             <a:ext cx="5238750" cy="2946797"/>
           </a:xfrm>
-          <a:prstGeom xmlns:a="http://schemas.openxmlformats.org/drawingml/2006/main" prst="rect">
+          <a:prstGeom prst="rect">
             <a:avLst/>
           </a:prstGeom>
         </p:spPr>
@@ -16480,6 +16788,30 @@
           </a:p>
         </p:txBody>
       </p:sp>
+      <p:pic xmlns:a="http://schemas.openxmlformats.org/drawingml/2006/main" xmlns:r="http://schemas.openxmlformats.org/officeDocument/2006/relationships">
+        <p:nvPicPr>
+          <p:cNvPr id="106" name="Pagemi Logo 03 footer" descr="pagemi-mark.png"/>
+          <p:cNvPicPr>
+            <a:picLocks noChangeAspect="1"/>
+          </p:cNvPicPr>
+          <p:nvPr/>
+        </p:nvPicPr>
+        <p:blipFill>
+          <a:blip r:embed="rId6"/>
+          <a:stretch>
+            <a:fillRect/>
+          </a:stretch>
+        </p:blipFill>
+        <p:spPr>
+          <a:xfrm>
+            <a:off x="8284464" y="4590288"/>
+            <a:ext cx="411480" cy="411480"/>
+          </a:xfrm>
+          <a:prstGeom prst="rect">
+            <a:avLst/>
+          </a:prstGeom>
+        </p:spPr>
+      </p:pic>
     </p:spTree>
     <p:extLst>
       <p:ext uri="{BB962C8B-B14F-4D97-AF65-F5344CB8AC3E}">
@@ -18502,6 +18834,30 @@
           </a:p>
         </p:txBody>
       </p:sp>
+      <p:pic xmlns:a="http://schemas.openxmlformats.org/drawingml/2006/main" xmlns:r="http://schemas.openxmlformats.org/officeDocument/2006/relationships">
+        <p:nvPicPr>
+          <p:cNvPr id="122" name="Pagemi Logo 03 footer" descr="pagemi-mark.png"/>
+          <p:cNvPicPr>
+            <a:picLocks noChangeAspect="1"/>
+          </p:cNvPicPr>
+          <p:nvPr/>
+        </p:nvPicPr>
+        <p:blipFill>
+          <a:blip r:embed="rId5"/>
+          <a:stretch>
+            <a:fillRect/>
+          </a:stretch>
+        </p:blipFill>
+        <p:spPr>
+          <a:xfrm>
+            <a:off x="8284464" y="4590288"/>
+            <a:ext cx="411480" cy="411480"/>
+          </a:xfrm>
+          <a:prstGeom prst="rect">
+            <a:avLst/>
+          </a:prstGeom>
+        </p:spPr>
+      </p:pic>
     </p:spTree>
     <p:extLst>
       <p:ext uri="{BB962C8B-B14F-4D97-AF65-F5344CB8AC3E}">
@@ -19077,6 +19433,30 @@
           </a:p>
         </p:txBody>
       </p:sp>
+      <p:pic xmlns:a="http://schemas.openxmlformats.org/drawingml/2006/main" xmlns:r="http://schemas.openxmlformats.org/officeDocument/2006/relationships">
+        <p:nvPicPr>
+          <p:cNvPr id="121" name="Pagemi Logo 03 footer" descr="pagemi-mark.png"/>
+          <p:cNvPicPr>
+            <a:picLocks noChangeAspect="1"/>
+          </p:cNvPicPr>
+          <p:nvPr/>
+        </p:nvPicPr>
+        <p:blipFill>
+          <a:blip r:embed="rId5"/>
+          <a:stretch>
+            <a:fillRect/>
+          </a:stretch>
+        </p:blipFill>
+        <p:spPr>
+          <a:xfrm>
+            <a:off x="8284464" y="4590288"/>
+            <a:ext cx="411480" cy="411480"/>
+          </a:xfrm>
+          <a:prstGeom prst="rect">
+            <a:avLst/>
+          </a:prstGeom>
+        </p:spPr>
+      </p:pic>
     </p:spTree>
     <p:extLst>
       <p:ext uri="{BB962C8B-B14F-4D97-AF65-F5344CB8AC3E}">

</xml_diff>